<commit_message>
feat(templates): one layout contract for the dark and light templates
Co-Authored-By: Claude Opus 5.5 <noreply@anthropic.com>
</commit_message>
<xml_diff>
--- a/inst/extdata/hv_ppt_template_light.pptx
+++ b/inst/extdata/hv_ppt_template_light.pptx
@@ -878,7 +878,7 @@
 
 <file path=ppt/slideLayouts/slideLayout1.xml><?xml version="1.0" encoding="utf-8"?>
 <p:sldLayout xmlns:a="http://schemas.openxmlformats.org/drawingml/2006/main" xmlns:r="http://schemas.openxmlformats.org/officeDocument/2006/relationships" xmlns:p="http://schemas.openxmlformats.org/presentationml/2006/main" type="title" preserve="1">
-  <p:cSld name="1_Title Slide">
+  <p:cSld name="Title Slide">
     <p:spTree>
       <p:nvGrpSpPr>
         <p:cNvPr id="1" name=""/>
@@ -1506,7 +1506,7 @@
 
 <file path=ppt/slideLayouts/slideLayout2.xml><?xml version="1.0" encoding="utf-8"?>
 <p:sldLayout xmlns:a="http://schemas.openxmlformats.org/drawingml/2006/main" xmlns:r="http://schemas.openxmlformats.org/officeDocument/2006/relationships" xmlns:p="http://schemas.openxmlformats.org/presentationml/2006/main" preserve="1" userDrawn="1">
-  <p:cSld name="1_Custom Layout">
+  <p:cSld name="Section Header">
     <p:spTree>
       <p:nvGrpSpPr>
         <p:cNvPr id="1" name=""/>
@@ -1573,7 +1573,7 @@
 
 <file path=ppt/slideLayouts/slideLayout3.xml><?xml version="1.0" encoding="utf-8"?>
 <p:sldLayout xmlns:a="http://schemas.openxmlformats.org/drawingml/2006/main" xmlns:r="http://schemas.openxmlformats.org/officeDocument/2006/relationships" xmlns:p="http://schemas.openxmlformats.org/presentationml/2006/main" preserve="1" userDrawn="1">
-  <p:cSld name="Title Slide">
+  <p:cSld name="Title Slide Background">
     <p:spTree>
       <p:nvGrpSpPr>
         <p:cNvPr id="1" name=""/>
@@ -1985,7 +1985,7 @@
 
 <file path=ppt/slideLayouts/slideLayout6.xml><?xml version="1.0" encoding="utf-8"?>
 <p:sldLayout xmlns:a="http://schemas.openxmlformats.org/drawingml/2006/main" xmlns:r="http://schemas.openxmlformats.org/officeDocument/2006/relationships" xmlns:p="http://schemas.openxmlformats.org/presentationml/2006/main" preserve="1" userDrawn="1">
-  <p:cSld name="Custom Layout">
+  <p:cSld name="Title Only">
     <p:spTree>
       <p:nvGrpSpPr>
         <p:cNvPr id="1" name=""/>

</xml_diff>